<commit_message>
Add student IDs to title-page author lists, include Theophilus Owusu-Manu
Adds each member's student ID next to their name on the two genuine
title pages in the repo: the technical report's author line and the
final defence deck's title slide. Also adds Theophilus Owusu-Manu, the
5th team member (known from the Week 4 meeting log but not previously
listed as an author anywhere). Regenerated final_defence_deck.pptx
from the updated build script — it had never picked up the earlier
CPEN 438 course-code fix either, since it's a binary, not
pandoc-generated.
</commit_message>
<xml_diff>
--- a/presentation/final_defence_deck.pptx
+++ b/presentation/final_defence_deck.pptx
@@ -3152,7 +3152,7 @@
               </a:defRPr>
             </a:pPr>
             <a:r>
-              <a:t>Final Defence — Project 1, Group 3, CPEN 315/733</a:t>
+              <a:t>Final Defence — Project 1, Group 3, CPEN 438</a:t>
             </a:r>
           </a:p>
           <a:p>
@@ -3164,7 +3164,7 @@
               </a:defRPr>
             </a:pPr>
             <a:r>
-              <a:t>Samuel Kojo Anafi Antwi · Amponsah Jonathan Boadu · Kumi Kelvin Gyabaah · Obed Ninson</a:t>
+              <a:t>Samuel Kojo Anafi Antwi (11164744) · Amponsah Jonathan Boadu (11293871) · Kumi Kelvin Gyabaah (11012343) · Obed Ninson (11238291) · Theophilus Owusu-Manu (10985130)</a:t>
             </a:r>
           </a:p>
         </p:txBody>

</xml_diff>